<commit_message>
Update Jig's pitch deck slides
</commit_message>
<xml_diff>
--- a/compass-pitch-jig.pptx
+++ b/compass-pitch-jig.pptx
@@ -3173,7 +3173,7 @@
                 <a:solidFill>
                   <a:srgbClr val="FFFFFF"/>
                 </a:solidFill>
-                <a:latin typeface="Open Sans"/>
+                <a:latin typeface="Helvetica Neue"/>
               </a:rPr>
               <a:t>Decision Hack Rhein-Neckar 2026</a:t>
             </a:r>
@@ -3208,7 +3208,7 @@
                 <a:solidFill>
                   <a:srgbClr val="C9C7D6"/>
                 </a:solidFill>
-                <a:latin typeface="Open Sans"/>
+                <a:latin typeface="Helvetica Neue"/>
               </a:rPr>
               <a:t>Team Compass   ·   paretos</a:t>
             </a:r>
@@ -3243,7 +3243,7 @@
                 <a:solidFill>
                   <a:srgbClr val="0D0A1E"/>
                 </a:solidFill>
-                <a:latin typeface="Open Sans"/>
+                <a:latin typeface="Helvetica Neue"/>
               </a:rPr>
               <a:t>Compass</a:t>
             </a:r>
@@ -3321,7 +3321,7 @@
                 <a:solidFill>
                   <a:srgbClr val="333344"/>
                 </a:solidFill>
-                <a:latin typeface="Open Sans"/>
+                <a:latin typeface="Helvetica Neue"/>
               </a:rPr>
               <a:t>Decision Intelligence for Demand Planning</a:t>
             </a:r>
@@ -3356,7 +3356,7 @@
                 <a:solidFill>
                   <a:srgbClr val="777788"/>
                 </a:solidFill>
-                <a:latin typeface="Open Sans"/>
+                <a:latin typeface="Helvetica Neue"/>
               </a:rPr>
               <a:t>Decision Hack Rhein-Neckar 2026    ·    Team Compass    ·    Track 2: Commit To The Plan</a:t>
             </a:r>
@@ -3434,7 +3434,8 @@
                 <a:solidFill>
                   <a:srgbClr val="FFFFFF"/>
                 </a:solidFill>
-                <a:latin typeface="Open Sans"/>
+                <a:latin typeface="Helvetica Neue"/>
+                <a:hlinkClick r:id="rId2"/>
               </a:rPr>
               <a:t>compass-frontend-seven.vercel.app</a:t>
             </a:r>
@@ -3538,7 +3539,7 @@
                 <a:solidFill>
                   <a:srgbClr val="FFFFFF"/>
                 </a:solidFill>
-                <a:latin typeface="Open Sans"/>
+                <a:latin typeface="Helvetica Neue"/>
               </a:rPr>
               <a:t>Decision Hack Rhein-Neckar 2026</a:t>
             </a:r>
@@ -3573,7 +3574,7 @@
                 <a:solidFill>
                   <a:srgbClr val="C9C7D6"/>
                 </a:solidFill>
-                <a:latin typeface="Open Sans"/>
+                <a:latin typeface="Helvetica Neue"/>
               </a:rPr>
               <a:t>Team Compass   ·   paretos</a:t>
             </a:r>
@@ -3608,7 +3609,7 @@
                 <a:solidFill>
                   <a:srgbClr val="0D0A1E"/>
                 </a:solidFill>
-                <a:latin typeface="Open Sans"/>
+                <a:latin typeface="Helvetica Neue"/>
               </a:rPr>
               <a:t>01   ·   WHAT IS COMPASS</a:t>
             </a:r>
@@ -3643,7 +3644,7 @@
                 <a:solidFill>
                   <a:srgbClr val="0D0A1E"/>
                 </a:solidFill>
-                <a:latin typeface="Open Sans"/>
+                <a:latin typeface="Helvetica Neue"/>
               </a:rPr>
               <a:t>Compass</a:t>
             </a:r>
@@ -3678,7 +3679,7 @@
                 <a:solidFill>
                   <a:srgbClr val="333344"/>
                 </a:solidFill>
-                <a:latin typeface="Open Sans"/>
+                <a:latin typeface="Helvetica Neue"/>
               </a:rPr>
               <a:t>A decision support tool that coaches every override, scores every outcome, and never forgets.</a:t>
             </a:r>
@@ -3801,7 +3802,7 @@
                 <a:solidFill>
                   <a:srgbClr val="0D0A1E"/>
                 </a:solidFill>
-                <a:latin typeface="Open Sans"/>
+                <a:latin typeface="Helvetica Neue"/>
               </a:rPr>
               <a:t>Coach</a:t>
             </a:r>
@@ -3836,7 +3837,7 @@
                 <a:solidFill>
                   <a:srgbClr val="333344"/>
                 </a:solidFill>
-                <a:latin typeface="Open Sans"/>
+                <a:latin typeface="Helvetica Neue"/>
               </a:rPr>
               <a:t>Before the planner commits, five AI agents check the real data from different angles and propose a better number with a confidence level.</a:t>
             </a:r>
@@ -3959,7 +3960,7 @@
                 <a:solidFill>
                   <a:srgbClr val="0D0A1E"/>
                 </a:solidFill>
-                <a:latin typeface="Open Sans"/>
+                <a:latin typeface="Helvetica Neue"/>
               </a:rPr>
               <a:t>Score</a:t>
             </a:r>
@@ -3994,7 +3995,7 @@
                 <a:solidFill>
                   <a:srgbClr val="333344"/>
                 </a:solidFill>
-                <a:latin typeface="Open Sans"/>
+                <a:latin typeface="Helvetica Neue"/>
               </a:rPr>
               <a:t>When real sales come in, every change the planner made gets graded. Was it better or worse than the original forecast? The gap is the lesson.</a:t>
             </a:r>
@@ -4117,7 +4118,7 @@
                 <a:solidFill>
                   <a:srgbClr val="0D0A1E"/>
                 </a:solidFill>
-                <a:latin typeface="Open Sans"/>
+                <a:latin typeface="Helvetica Neue"/>
               </a:rPr>
               <a:t>Remember</a:t>
             </a:r>
@@ -4152,7 +4153,7 @@
                 <a:solidFill>
                   <a:srgbClr val="333344"/>
                 </a:solidFill>
-                <a:latin typeface="Open Sans"/>
+                <a:latin typeface="Helvetica Neue"/>
               </a:rPr>
               <a:t>Every graded outcome is saved. The next time a similar situation comes up, Compass shows the planner what happened last time and who was right.</a:t>
             </a:r>
@@ -4230,7 +4231,7 @@
                 <a:solidFill>
                   <a:srgbClr val="FFFFFF"/>
                 </a:solidFill>
-                <a:latin typeface="Open Sans"/>
+                <a:latin typeface="Helvetica Neue"/>
               </a:rPr>
               <a:t>The planner always makes the final call. Compass makes sure they make it with evidence.</a:t>
             </a:r>
@@ -4334,7 +4335,7 @@
                 <a:solidFill>
                   <a:srgbClr val="FFFFFF"/>
                 </a:solidFill>
-                <a:latin typeface="Open Sans"/>
+                <a:latin typeface="Helvetica Neue"/>
               </a:rPr>
               <a:t>Decision Hack Rhein-Neckar 2026</a:t>
             </a:r>
@@ -4369,7 +4370,7 @@
                 <a:solidFill>
                   <a:srgbClr val="C9C7D6"/>
                 </a:solidFill>
-                <a:latin typeface="Open Sans"/>
+                <a:latin typeface="Helvetica Neue"/>
               </a:rPr>
               <a:t>Team Compass   ·   paretos</a:t>
             </a:r>
@@ -4404,7 +4405,7 @@
                 <a:solidFill>
                   <a:srgbClr val="0D0A1E"/>
                 </a:solidFill>
-                <a:latin typeface="Open Sans"/>
+                <a:latin typeface="Helvetica Neue"/>
               </a:rPr>
               <a:t>02   ·   THE PROBLEM</a:t>
             </a:r>
@@ -4439,7 +4440,7 @@
                 <a:solidFill>
                   <a:srgbClr val="0D0A1E"/>
                 </a:solidFill>
-                <a:latin typeface="Open Sans"/>
+                <a:latin typeface="Helvetica Neue"/>
               </a:rPr>
               <a:t>Planners override the system every single time</a:t>
             </a:r>
@@ -4455,7 +4456,7 @@
         <p:spPr>
           <a:xfrm>
             <a:off x="457200" y="2057400"/>
-            <a:ext cx="4663440" cy="2240280"/>
+            <a:ext cx="5394960" cy="2240280"/>
           </a:xfrm>
           <a:prstGeom prst="rect">
             <a:avLst/>
@@ -4500,7 +4501,7 @@
         <p:spPr>
           <a:xfrm>
             <a:off x="457200" y="2057400"/>
-            <a:ext cx="4663440" cy="64008"/>
+            <a:ext cx="5394960" cy="64008"/>
           </a:xfrm>
           <a:prstGeom prst="rect">
             <a:avLst/>
@@ -4542,8 +4543,8 @@
         </p:nvSpPr>
         <p:spPr>
           <a:xfrm>
-            <a:off x="685800" y="2194560"/>
-            <a:ext cx="4114800" cy="1005840"/>
+            <a:off x="731520" y="2194560"/>
+            <a:ext cx="4846320" cy="1005840"/>
           </a:xfrm>
           <a:prstGeom prst="rect">
             <a:avLst/>
@@ -4562,7 +4563,7 @@
                 <a:solidFill>
                   <a:srgbClr val="F500E1"/>
                 </a:solidFill>
-                <a:latin typeface="Open Sans"/>
+                <a:latin typeface="Helvetica Neue"/>
               </a:rPr>
               <a:t>99.8%</a:t>
             </a:r>
@@ -4577,8 +4578,8 @@
         </p:nvSpPr>
         <p:spPr>
           <a:xfrm>
-            <a:off x="685800" y="3108960"/>
-            <a:ext cx="4114800" cy="731520"/>
+            <a:off x="731520" y="3127248"/>
+            <a:ext cx="4846320" cy="822960"/>
           </a:xfrm>
           <a:prstGeom prst="rect">
             <a:avLst/>
@@ -4597,10 +4598,9 @@
                 <a:solidFill>
                   <a:srgbClr val="333344"/>
                 </a:solidFill>
-                <a:latin typeface="Open Sans"/>
+                <a:latin typeface="Helvetica Neue"/>
               </a:rPr>
-              <a:t>of forecasts are manually
-changed before committed</a:t>
+              <a:t>of forecasts are manually changed before committed</a:t>
             </a:r>
           </a:p>
         </p:txBody>
@@ -4613,8 +4613,8 @@
         </p:nvSpPr>
         <p:spPr>
           <a:xfrm>
-            <a:off x="5486400" y="2057400"/>
-            <a:ext cx="4663440" cy="2240280"/>
+            <a:off x="6336792" y="2057400"/>
+            <a:ext cx="5394960" cy="2240280"/>
           </a:xfrm>
           <a:prstGeom prst="rect">
             <a:avLst/>
@@ -4658,8 +4658,8 @@
         </p:nvSpPr>
         <p:spPr>
           <a:xfrm>
-            <a:off x="5486400" y="2057400"/>
-            <a:ext cx="4663440" cy="64008"/>
+            <a:off x="6336792" y="2057400"/>
+            <a:ext cx="5394960" cy="64008"/>
           </a:xfrm>
           <a:prstGeom prst="rect">
             <a:avLst/>
@@ -4701,8 +4701,8 @@
         </p:nvSpPr>
         <p:spPr>
           <a:xfrm>
-            <a:off x="5715000" y="2194560"/>
-            <a:ext cx="4114800" cy="1005840"/>
+            <a:off x="6611112" y="2194560"/>
+            <a:ext cx="4846320" cy="1005840"/>
           </a:xfrm>
           <a:prstGeom prst="rect">
             <a:avLst/>
@@ -4721,7 +4721,7 @@
                 <a:solidFill>
                   <a:srgbClr val="F500E1"/>
                 </a:solidFill>
-                <a:latin typeface="Open Sans"/>
+                <a:latin typeface="Helvetica Neue"/>
               </a:rPr>
               <a:t>39%</a:t>
             </a:r>
@@ -4736,8 +4736,8 @@
         </p:nvSpPr>
         <p:spPr>
           <a:xfrm>
-            <a:off x="5715000" y="3108960"/>
-            <a:ext cx="4114800" cy="731520"/>
+            <a:off x="6611112" y="3127248"/>
+            <a:ext cx="4846320" cy="822960"/>
           </a:xfrm>
           <a:prstGeom prst="rect">
             <a:avLst/>
@@ -4756,10 +4756,9 @@
                 <a:solidFill>
                   <a:srgbClr val="333344"/>
                 </a:solidFill>
-                <a:latin typeface="Open Sans"/>
+                <a:latin typeface="Helvetica Neue"/>
               </a:rPr>
-              <a:t>of those changes make
-the forecast worse</a:t>
+              <a:t>of those changes make the forecast worse</a:t>
             </a:r>
           </a:p>
         </p:txBody>
@@ -4880,7 +4879,7 @@
                 <a:solidFill>
                   <a:srgbClr val="333344"/>
                 </a:solidFill>
-                <a:latin typeface="Open Sans"/>
+                <a:latin typeface="Helvetica Neue"/>
               </a:rPr>
               <a:t>Nobody tracks which changes helped and which did not</a:t>
             </a:r>
@@ -4896,17 +4895,17 @@
         <p:spPr>
           <a:xfrm>
             <a:off x="457200" y="5321808"/>
-            <a:ext cx="11155680" cy="960120"/>
+            <a:ext cx="11155680" cy="640080"/>
           </a:xfrm>
           <a:prstGeom prst="rect">
             <a:avLst/>
           </a:prstGeom>
           <a:solidFill>
-            <a:srgbClr val="FFF8EE"/>
+            <a:srgbClr val="F5F5F7"/>
           </a:solidFill>
           <a:ln w="9525">
             <a:solidFill>
-              <a:srgbClr val="FBB03B"/>
+              <a:srgbClr val="E0E0E8"/>
             </a:solidFill>
           </a:ln>
         </p:spPr>
@@ -4941,13 +4940,13 @@
         <p:spPr>
           <a:xfrm>
             <a:off x="457200" y="5321808"/>
-            <a:ext cx="64008" cy="960120"/>
+            <a:ext cx="54864" cy="640080"/>
           </a:xfrm>
           <a:prstGeom prst="rect">
             <a:avLst/>
           </a:prstGeom>
           <a:solidFill>
-            <a:srgbClr val="FBB03B"/>
+            <a:srgbClr val="F500E1"/>
           </a:solidFill>
           <a:ln>
             <a:noFill/>
@@ -4983,8 +4982,8 @@
         </p:nvSpPr>
         <p:spPr>
           <a:xfrm>
-            <a:off x="685800" y="5504688"/>
-            <a:ext cx="10698480" cy="640080"/>
+            <a:off x="685800" y="5468112"/>
+            <a:ext cx="10698480" cy="457200"/>
           </a:xfrm>
           <a:prstGeom prst="rect">
             <a:avLst/>
@@ -4999,11 +4998,11 @@
           <a:p>
             <a:pPr algn="l"/>
             <a:r>
-              <a:rPr sz="1400" b="0" i="1">
-                <a:solidFill>
-                  <a:srgbClr val="996600"/>
-                </a:solidFill>
-                <a:latin typeface="Open Sans"/>
+              <a:rPr sz="1400" b="1" i="0">
+                <a:solidFill>
+                  <a:srgbClr val="333344"/>
+                </a:solidFill>
+                <a:latin typeface="Helvetica Neue"/>
               </a:rPr>
               <a:t>When the planner retires, every lesson they learned walks out the door with them.</a:t>
             </a:r>
@@ -5107,7 +5106,7 @@
                 <a:solidFill>
                   <a:srgbClr val="FFFFFF"/>
                 </a:solidFill>
-                <a:latin typeface="Open Sans"/>
+                <a:latin typeface="Helvetica Neue"/>
               </a:rPr>
               <a:t>Decision Hack Rhein-Neckar 2026</a:t>
             </a:r>
@@ -5142,7 +5141,7 @@
                 <a:solidFill>
                   <a:srgbClr val="C9C7D6"/>
                 </a:solidFill>
-                <a:latin typeface="Open Sans"/>
+                <a:latin typeface="Helvetica Neue"/>
               </a:rPr>
               <a:t>Team Compass   ·   paretos</a:t>
             </a:r>
@@ -5177,7 +5176,7 @@
                 <a:solidFill>
                   <a:srgbClr val="0D0A1E"/>
                 </a:solidFill>
-                <a:latin typeface="Open Sans"/>
+                <a:latin typeface="Helvetica Neue"/>
               </a:rPr>
               <a:t>03   ·   WHAT WE BUILT</a:t>
             </a:r>
@@ -5212,7 +5211,7 @@
                 <a:solidFill>
                   <a:srgbClr val="0D0A1E"/>
                 </a:solidFill>
-                <a:latin typeface="Open Sans"/>
+                <a:latin typeface="Helvetica Neue"/>
               </a:rPr>
               <a:t>End to end in 23 real Alpine planning cycles</a:t>
             </a:r>
@@ -5247,7 +5246,7 @@
                 <a:solidFill>
                   <a:srgbClr val="777788"/>
                 </a:solidFill>
-                <a:latin typeface="Open Sans"/>
+                <a:latin typeface="Helvetica Neue"/>
               </a:rPr>
               <a:t>HOW IT WORKS</a:t>
             </a:r>
@@ -5325,7 +5324,7 @@
                 <a:solidFill>
                   <a:srgbClr val="FFFFFF"/>
                 </a:solidFill>
-                <a:latin typeface="Open Sans"/>
+                <a:latin typeface="Helvetica Neue"/>
               </a:rPr>
               <a:t>1</a:t>
             </a:r>
@@ -5360,7 +5359,7 @@
                 <a:solidFill>
                   <a:srgbClr val="333344"/>
                 </a:solidFill>
-                <a:latin typeface="Open Sans"/>
+                <a:latin typeface="Helvetica Neue"/>
               </a:rPr>
               <a:t>Planner proposes a number and types a reason</a:t>
             </a:r>
@@ -5438,7 +5437,7 @@
                 <a:solidFill>
                   <a:srgbClr val="FFFFFF"/>
                 </a:solidFill>
-                <a:latin typeface="Open Sans"/>
+                <a:latin typeface="Helvetica Neue"/>
               </a:rPr>
               <a:t>2</a:t>
             </a:r>
@@ -5473,7 +5472,7 @@
                 <a:solidFill>
                   <a:srgbClr val="333344"/>
                 </a:solidFill>
-                <a:latin typeface="Open Sans"/>
+                <a:latin typeface="Helvetica Neue"/>
               </a:rPr>
               <a:t>Five AI agents check the real data from different angles</a:t>
             </a:r>
@@ -5551,7 +5550,7 @@
                 <a:solidFill>
                   <a:srgbClr val="FFFFFF"/>
                 </a:solidFill>
-                <a:latin typeface="Open Sans"/>
+                <a:latin typeface="Helvetica Neue"/>
               </a:rPr>
               <a:t>3</a:t>
             </a:r>
@@ -5586,7 +5585,7 @@
                 <a:solidFill>
                   <a:srgbClr val="333344"/>
                 </a:solidFill>
-                <a:latin typeface="Open Sans"/>
+                <a:latin typeface="Helvetica Neue"/>
               </a:rPr>
               <a:t>A coordinator reviews all five and suggests a better number with a confidence level</a:t>
             </a:r>
@@ -5664,7 +5663,7 @@
                 <a:solidFill>
                   <a:srgbClr val="FFFFFF"/>
                 </a:solidFill>
-                <a:latin typeface="Open Sans"/>
+                <a:latin typeface="Helvetica Neue"/>
               </a:rPr>
               <a:t>4</a:t>
             </a:r>
@@ -5699,7 +5698,7 @@
                 <a:solidFill>
                   <a:srgbClr val="333344"/>
                 </a:solidFill>
-                <a:latin typeface="Open Sans"/>
+                <a:latin typeface="Helvetica Neue"/>
               </a:rPr>
               <a:t>When real sales come in, every decision is graded automatically</a:t>
             </a:r>
@@ -5779,7 +5778,7 @@
                 <a:solidFill>
                   <a:srgbClr val="777788"/>
                 </a:solidFill>
-                <a:latin typeface="Open Sans"/>
+                <a:latin typeface="Helvetica Neue"/>
               </a:rPr>
               <a:t>THE FIVE AGENTS</a:t>
             </a:r>
@@ -5814,7 +5813,7 @@
                 <a:solidFill>
                   <a:srgbClr val="0D0A1E"/>
                 </a:solidFill>
-                <a:latin typeface="Open Sans"/>
+                <a:latin typeface="Helvetica Neue"/>
               </a:rPr>
               <a:t>Demand</a:t>
             </a:r>
@@ -5849,7 +5848,7 @@
                 <a:solidFill>
                   <a:srgbClr val="333344"/>
                 </a:solidFill>
-                <a:latin typeface="Open Sans"/>
+                <a:latin typeface="Helvetica Neue"/>
               </a:rPr>
               <a:t>Future orders, customers, returns</a:t>
             </a:r>
@@ -5884,7 +5883,7 @@
                 <a:solidFill>
                   <a:srgbClr val="0D0A1E"/>
                 </a:solidFill>
-                <a:latin typeface="Open Sans"/>
+                <a:latin typeface="Helvetica Neue"/>
               </a:rPr>
               <a:t>Supply</a:t>
             </a:r>
@@ -5919,7 +5918,7 @@
                 <a:solidFill>
                   <a:srgbClr val="333344"/>
                 </a:solidFill>
-                <a:latin typeface="Open Sans"/>
+                <a:latin typeface="Helvetica Neue"/>
               </a:rPr>
               <a:t>Stock levels, purchase orders, production</a:t>
             </a:r>
@@ -5954,7 +5953,7 @@
                 <a:solidFill>
                   <a:srgbClr val="0D0A1E"/>
                 </a:solidFill>
-                <a:latin typeface="Open Sans"/>
+                <a:latin typeface="Helvetica Neue"/>
               </a:rPr>
               <a:t>Finance</a:t>
             </a:r>
@@ -5989,7 +5988,7 @@
                 <a:solidFill>
                   <a:srgbClr val="333344"/>
                 </a:solidFill>
-                <a:latin typeface="Open Sans"/>
+                <a:latin typeface="Helvetica Neue"/>
               </a:rPr>
               <a:t>Business plan, margins, cost breakdown</a:t>
             </a:r>
@@ -6024,7 +6023,7 @@
                 <a:solidFill>
                   <a:srgbClr val="0D0A1E"/>
                 </a:solidFill>
-                <a:latin typeface="Open Sans"/>
+                <a:latin typeface="Helvetica Neue"/>
               </a:rPr>
               <a:t>Commercial</a:t>
             </a:r>
@@ -6059,7 +6058,7 @@
                 <a:solidFill>
                   <a:srgbClr val="333344"/>
                 </a:solidFill>
-                <a:latin typeface="Open Sans"/>
+                <a:latin typeface="Helvetica Neue"/>
               </a:rPr>
               <a:t>Marketing spend, price changes, market signals</a:t>
             </a:r>
@@ -6094,7 +6093,7 @@
                 <a:solidFill>
                   <a:srgbClr val="0D0A1E"/>
                 </a:solidFill>
-                <a:latin typeface="Open Sans"/>
+                <a:latin typeface="Helvetica Neue"/>
               </a:rPr>
               <a:t>Memory</a:t>
             </a:r>
@@ -6129,7 +6128,7 @@
                 <a:solidFill>
                   <a:srgbClr val="333344"/>
                 </a:solidFill>
-                <a:latin typeface="Open Sans"/>
+                <a:latin typeface="Helvetica Neue"/>
               </a:rPr>
               <a:t>Full record of past decisions and whether they paid off</a:t>
             </a:r>
@@ -6207,7 +6206,7 @@
                 <a:solidFill>
                   <a:srgbClr val="FFFFFF"/>
                 </a:solidFill>
-                <a:latin typeface="Open Sans"/>
+                <a:latin typeface="Helvetica Neue"/>
               </a:rPr>
               <a:t>68,126 forecast changes reviewed across 23 real planning cycles</a:t>
             </a:r>
@@ -6311,7 +6310,7 @@
                 <a:solidFill>
                   <a:srgbClr val="FFFFFF"/>
                 </a:solidFill>
-                <a:latin typeface="Open Sans"/>
+                <a:latin typeface="Helvetica Neue"/>
               </a:rPr>
               <a:t>Decision Hack Rhein-Neckar 2026</a:t>
             </a:r>
@@ -6346,7 +6345,7 @@
                 <a:solidFill>
                   <a:srgbClr val="C9C7D6"/>
                 </a:solidFill>
-                <a:latin typeface="Open Sans"/>
+                <a:latin typeface="Helvetica Neue"/>
               </a:rPr>
               <a:t>Team Compass   ·   paretos</a:t>
             </a:r>
@@ -6381,7 +6380,7 @@
                 <a:solidFill>
                   <a:srgbClr val="0D0A1E"/>
                 </a:solidFill>
-                <a:latin typeface="Open Sans"/>
+                <a:latin typeface="Helvetica Neue"/>
               </a:rPr>
               <a:t>04   ·   WHAT WE LEARNED</a:t>
             </a:r>
@@ -6416,7 +6415,7 @@
                 <a:solidFill>
                   <a:srgbClr val="0D0A1E"/>
                 </a:solidFill>
-                <a:latin typeface="Open Sans"/>
+                <a:latin typeface="Helvetica Neue"/>
               </a:rPr>
               <a:t>We hit real walls and learned from them</a:t>
             </a:r>
@@ -6539,7 +6538,7 @@
                 <a:solidFill>
                   <a:srgbClr val="996600"/>
                 </a:solidFill>
-                <a:latin typeface="Open Sans"/>
+                <a:latin typeface="Helvetica Neue"/>
               </a:rPr>
               <a:t>Speed</a:t>
             </a:r>
@@ -6574,7 +6573,7 @@
                 <a:solidFill>
                   <a:srgbClr val="333344"/>
                 </a:solidFill>
-                <a:latin typeface="Open Sans"/>
+                <a:latin typeface="Helvetica Neue"/>
               </a:rPr>
               <a:t>AI responses were too slow for a smooth live demo. We prepared answers in advance so the flow feels instant.</a:t>
             </a:r>
@@ -6697,7 +6696,7 @@
                 <a:solidFill>
                   <a:srgbClr val="996600"/>
                 </a:solidFill>
-                <a:latin typeface="Open Sans"/>
+                <a:latin typeface="Helvetica Neue"/>
               </a:rPr>
               <a:t>Data coverage</a:t>
             </a:r>
@@ -6732,7 +6731,7 @@
                 <a:solidFill>
                   <a:srgbClr val="333344"/>
                 </a:solidFill>
-                <a:latin typeface="Open Sans"/>
+                <a:latin typeface="Helvetica Neue"/>
               </a:rPr>
               <a:t>Only two of the five agents are fully connected to real data. The other three use partial information.</a:t>
             </a:r>
@@ -6855,7 +6854,7 @@
                 <a:solidFill>
                   <a:srgbClr val="996600"/>
                 </a:solidFill>
-                <a:latin typeface="Open Sans"/>
+                <a:latin typeface="Helvetica Neue"/>
               </a:rPr>
               <a:t>Consistency</a:t>
             </a:r>
@@ -6890,7 +6889,7 @@
                 <a:solidFill>
                   <a:srgbClr val="333344"/>
                 </a:solidFill>
-                <a:latin typeface="Open Sans"/>
+                <a:latin typeface="Helvetica Neue"/>
               </a:rPr>
               <a:t>Asking the same question twice sometimes gave slightly different answers from the AI.</a:t>
             </a:r>
@@ -7013,7 +7012,7 @@
                 <a:solidFill>
                   <a:srgbClr val="996600"/>
                 </a:solidFill>
-                <a:latin typeface="Open Sans"/>
+                <a:latin typeface="Helvetica Neue"/>
               </a:rPr>
               <a:t>Live grading</a:t>
             </a:r>
@@ -7048,7 +7047,7 @@
                 <a:solidFill>
                   <a:srgbClr val="333344"/>
                 </a:solidFill>
-                <a:latin typeface="Open Sans"/>
+                <a:latin typeface="Helvetica Neue"/>
               </a:rPr>
               <a:t>The system grades past decisions accurately. It is not yet connected to incoming sales data automatically.</a:t>
             </a:r>
@@ -7126,7 +7125,7 @@
                 <a:solidFill>
                   <a:srgbClr val="FFFFFF"/>
                 </a:solidFill>
-                <a:latin typeface="Open Sans"/>
+                <a:latin typeface="Helvetica Neue"/>
               </a:rPr>
               <a:t>None of these is a blocker. The core mechanic works end to end.</a:t>
             </a:r>
@@ -7230,7 +7229,7 @@
                 <a:solidFill>
                   <a:srgbClr val="FFFFFF"/>
                 </a:solidFill>
-                <a:latin typeface="Open Sans"/>
+                <a:latin typeface="Helvetica Neue"/>
               </a:rPr>
               <a:t>Decision Hack Rhein-Neckar 2026</a:t>
             </a:r>
@@ -7265,7 +7264,7 @@
                 <a:solidFill>
                   <a:srgbClr val="C9C7D6"/>
                 </a:solidFill>
-                <a:latin typeface="Open Sans"/>
+                <a:latin typeface="Helvetica Neue"/>
               </a:rPr>
               <a:t>Team Compass   ·   paretos</a:t>
             </a:r>
@@ -7300,7 +7299,7 @@
                 <a:solidFill>
                   <a:srgbClr val="0D0A1E"/>
                 </a:solidFill>
-                <a:latin typeface="Open Sans"/>
+                <a:latin typeface="Helvetica Neue"/>
               </a:rPr>
               <a:t>05   ·   WHAT IS NEXT</a:t>
             </a:r>
@@ -7335,7 +7334,7 @@
                 <a:solidFill>
                   <a:srgbClr val="0D0A1E"/>
                 </a:solidFill>
-                <a:latin typeface="Open Sans"/>
+                <a:latin typeface="Helvetica Neue"/>
               </a:rPr>
               <a:t>A clear path to production</a:t>
             </a:r>
@@ -7501,7 +7500,7 @@
                 <a:solidFill>
                   <a:srgbClr val="FFFFFF"/>
                 </a:solidFill>
-                <a:latin typeface="Open Sans"/>
+                <a:latin typeface="Helvetica Neue"/>
               </a:rPr>
               <a:t>1</a:t>
             </a:r>
@@ -7536,7 +7535,7 @@
                 <a:solidFill>
                   <a:srgbClr val="0D0A1E"/>
                 </a:solidFill>
-                <a:latin typeface="Open Sans"/>
+                <a:latin typeface="Helvetica Neue"/>
               </a:rPr>
               <a:t>Stream the answers</a:t>
             </a:r>
@@ -7571,7 +7570,7 @@
                 <a:solidFill>
                   <a:srgbClr val="333344"/>
                 </a:solidFill>
-                <a:latin typeface="Open Sans"/>
+                <a:latin typeface="Helvetica Neue"/>
               </a:rPr>
               <a:t>Show each agent's finding the moment it lands, so the planner never waits.</a:t>
             </a:r>
@@ -7737,7 +7736,7 @@
                 <a:solidFill>
                   <a:srgbClr val="FFFFFF"/>
                 </a:solidFill>
-                <a:latin typeface="Open Sans"/>
+                <a:latin typeface="Helvetica Neue"/>
               </a:rPr>
               <a:t>2</a:t>
             </a:r>
@@ -7772,7 +7771,7 @@
                 <a:solidFill>
                   <a:srgbClr val="0D0A1E"/>
                 </a:solidFill>
-                <a:latin typeface="Open Sans"/>
+                <a:latin typeface="Helvetica Neue"/>
               </a:rPr>
               <a:t>Connect every agent</a:t>
             </a:r>
@@ -7807,7 +7806,7 @@
                 <a:solidFill>
                   <a:srgbClr val="333344"/>
                 </a:solidFill>
-                <a:latin typeface="Open Sans"/>
+                <a:latin typeface="Helvetica Neue"/>
               </a:rPr>
               <a:t>Ground Finance and Commercial on real data so all five agents speak from evidence.</a:t>
             </a:r>
@@ -7973,7 +7972,7 @@
                 <a:solidFill>
                   <a:srgbClr val="FFFFFF"/>
                 </a:solidFill>
-                <a:latin typeface="Open Sans"/>
+                <a:latin typeface="Helvetica Neue"/>
               </a:rPr>
               <a:t>3</a:t>
             </a:r>
@@ -8008,7 +8007,7 @@
                 <a:solidFill>
                   <a:srgbClr val="0D0A1E"/>
                 </a:solidFill>
-                <a:latin typeface="Open Sans"/>
+                <a:latin typeface="Helvetica Neue"/>
               </a:rPr>
               <a:t>Lock in consistency</a:t>
             </a:r>
@@ -8043,7 +8042,7 @@
                 <a:solidFill>
                   <a:srgbClr val="333344"/>
                 </a:solidFill>
-                <a:latin typeface="Open Sans"/>
+                <a:latin typeface="Helvetica Neue"/>
               </a:rPr>
               <a:t>Make the AI return the same answer to the same question, every time.</a:t>
             </a:r>
@@ -8209,7 +8208,7 @@
                 <a:solidFill>
                   <a:srgbClr val="FFFFFF"/>
                 </a:solidFill>
-                <a:latin typeface="Open Sans"/>
+                <a:latin typeface="Helvetica Neue"/>
               </a:rPr>
               <a:t>4</a:t>
             </a:r>
@@ -8244,7 +8243,7 @@
                 <a:solidFill>
                   <a:srgbClr val="0D0A1E"/>
                 </a:solidFill>
-                <a:latin typeface="Open Sans"/>
+                <a:latin typeface="Helvetica Neue"/>
               </a:rPr>
               <a:t>Wire up live grading</a:t>
             </a:r>
@@ -8279,7 +8278,7 @@
                 <a:solidFill>
                   <a:srgbClr val="333344"/>
                 </a:solidFill>
-                <a:latin typeface="Open Sans"/>
+                <a:latin typeface="Helvetica Neue"/>
               </a:rPr>
               <a:t>Connect to a live sales feed so decisions get scored automatically as actuals arrive.</a:t>
             </a:r>
@@ -8357,7 +8356,7 @@
                 <a:solidFill>
                   <a:srgbClr val="FFFFFF"/>
                 </a:solidFill>
-                <a:latin typeface="Open Sans"/>
+                <a:latin typeface="Helvetica Neue"/>
               </a:rPr>
               <a:t>The decision problem stays the same. The institution just keeps getting smarter.</a:t>
             </a:r>
@@ -8461,7 +8460,7 @@
                 <a:solidFill>
                   <a:srgbClr val="FFFFFF"/>
                 </a:solidFill>
-                <a:latin typeface="Open Sans"/>
+                <a:latin typeface="Helvetica Neue"/>
               </a:rPr>
               <a:t>Decision Hack Rhein-Neckar 2026</a:t>
             </a:r>
@@ -8496,7 +8495,7 @@
                 <a:solidFill>
                   <a:srgbClr val="C9C7D6"/>
                 </a:solidFill>
-                <a:latin typeface="Open Sans"/>
+                <a:latin typeface="Helvetica Neue"/>
               </a:rPr>
               <a:t>Team Compass   ·   paretos</a:t>
             </a:r>
@@ -8531,7 +8530,7 @@
                 <a:solidFill>
                   <a:srgbClr val="0D0A1E"/>
                 </a:solidFill>
-                <a:latin typeface="Open Sans"/>
+                <a:latin typeface="Helvetica Neue"/>
               </a:rPr>
               <a:t>Q&amp;A</a:t>
             </a:r>
@@ -8609,7 +8608,8 @@
                 <a:solidFill>
                   <a:srgbClr val="777788"/>
                 </a:solidFill>
-                <a:latin typeface="Open Sans"/>
+                <a:latin typeface="Helvetica Neue"/>
+                <a:hlinkClick r:id="rId2"/>
               </a:rPr>
               <a:t>compass-frontend-seven.vercel.app</a:t>
             </a:r>

</xml_diff>